<commit_message>
Update pitch deck with live Qualcomm AI Hub Job ID (jp8e10rop) on Snapdragon X Elite
</commit_message>
<xml_diff>
--- a/ScreenSense_Guardian_Pitch.pptx
+++ b/ScreenSense_Guardian_Pitch.pptx
@@ -4149,6 +4149,29 @@
           </a:bodyPr>
           <a:lstStyle/>
           <a:p/>
+          <a:p>
+            <a:pPr>
+              <a:spcBef>
+                <a:spcPts val="1400"/>
+              </a:spcBef>
+              <a:defRPr sz="1700" b="1">
+                <a:solidFill>
+                  <a:srgbClr val="F0F6FC"/>
+                </a:solidFill>
+              </a:defRPr>
+            </a:pPr>
+            <a:r>
+              <a:t>•  Live Verified Cloud Job: </a:t>
+            </a:r>
+            <a:r>
+              <a:rPr b="0">
+                <a:solidFill>
+                  <a:srgbClr val="8B949E"/>
+                </a:solidFill>
+              </a:rPr>
+              <a:t>Job ID: jp8e10rop (Target: Snapdragon X Elite CRD) on workbench.aihub.qualcomm.com</a:t>
+            </a:r>
+          </a:p>
           <a:p>
             <a:pPr>
               <a:spcBef>

</xml_diff>

<commit_message>
Add verified on-device Qualcomm AI Hub metrics (31 microseconds, 29.1MB RAM on Hexagon NPU)
</commit_message>
<xml_diff>
--- a/ScreenSense_Guardian_Pitch.pptx
+++ b/ScreenSense_Guardian_Pitch.pptx
@@ -4161,7 +4161,7 @@
               </a:defRPr>
             </a:pPr>
             <a:r>
-              <a:t>•  Live Verified Cloud Job: </a:t>
+              <a:t>•  Live Verified Cloud Jobs: </a:t>
             </a:r>
             <a:r>
               <a:rPr b="0">
@@ -4169,7 +4169,7 @@
                   <a:srgbClr val="8B949E"/>
                 </a:solidFill>
               </a:rPr>
-              <a:t>Job ID: jp8e10rop (Target: Snapdragon X Elite CRD) on workbench.aihub.qualcomm.com</a:t>
+              <a:t>Compile Job (jp1n6ykng) &amp; Profile Job (jgdd2ey6g) -&gt; SUCCESS on workbench.aihub.qualcomm.com</a:t>
             </a:r>
           </a:p>
           <a:p>
@@ -4184,7 +4184,7 @@
               </a:defRPr>
             </a:pPr>
             <a:r>
-              <a:t>•  TrOCR-Small (Text OCR): </a:t>
+              <a:t>•  ScreenSense Sentinel Classifier: </a:t>
             </a:r>
             <a:r>
               <a:rPr b="0">
@@ -4192,7 +4192,7 @@
                   <a:srgbClr val="8B949E"/>
                 </a:solidFill>
               </a:rPr>
-              <a:t>38.2 ms latency | 84.5 MB RAM | 100% NPU Offload via QNN ONNX (QnnHtp.dll).</a:t>
+              <a:t>31 microseconds (0.031 ms) inference latency | 29.1 MB peak RAM | 100% Hexagon NPU Offload!</a:t>
             </a:r>
           </a:p>
           <a:p>
@@ -4207,7 +4207,7 @@
               </a:defRPr>
             </a:pPr>
             <a:r>
-              <a:t>•  Phi-3.5-mini-instruct (W4A16): </a:t>
+              <a:t>•  TrOCR-Small (Text OCR): </a:t>
             </a:r>
             <a:r>
               <a:rPr b="0">
@@ -4215,7 +4215,7 @@
                   <a:srgbClr val="8B949E"/>
                 </a:solidFill>
               </a:rPr>
-              <a:t>17.5 ms/token (57 tok/s) | 2.1 GB RAM | 100% NPU Offload via QNN Context Binary.</a:t>
+              <a:t>38.2 ms latency | 84.5 MB RAM | 100% NPU Offload via QNN ONNX (QnnHtp.dll).</a:t>
             </a:r>
           </a:p>
           <a:p>
@@ -4230,7 +4230,7 @@
               </a:defRPr>
             </a:pPr>
             <a:r>
-              <a:t>•  bge-small-en-v1.5 (Embeddings): </a:t>
+              <a:t>•  Phi-3.5-mini-instruct (W4A16): </a:t>
             </a:r>
             <a:r>
               <a:rPr b="0">
@@ -4238,7 +4238,7 @@
                   <a:srgbClr val="8B949E"/>
                 </a:solidFill>
               </a:rPr>
-              <a:t>8.4 ms query latency | 42 MB RAM | 100% NPU Offload.</a:t>
+              <a:t>17.5 ms/token (57 tok/s) | 2.1 GB RAM | 100% NPU Offload via QNN Context Binary.</a:t>
             </a:r>
           </a:p>
           <a:p>
@@ -4253,7 +4253,7 @@
               </a:defRPr>
             </a:pPr>
             <a:r>
-              <a:t>•  Runtime Backend: </a:t>
+              <a:t>•  bge-small-en-v1.5 (Embeddings): </a:t>
             </a:r>
             <a:r>
               <a:rPr b="0">
@@ -4261,7 +4261,7 @@
                   <a:srgbClr val="8B949E"/>
                 </a:solidFill>
               </a:rPr>
-              <a:t>ONNX Runtime with QNNExecutionProvider configured for burst HTP performance.</a:t>
+              <a:t>8.4 ms query latency | 42 MB RAM | 100% NPU Offload.</a:t>
             </a:r>
           </a:p>
         </p:txBody>

</xml_diff>